<commit_message>
Align the Session 3 deck with the current notebook 03 (budget stop, failures)
Co-Authored-By: Claude Fable 5.1 <noreply@anthropic.com>
</commit_message>
<xml_diff>
--- a/presentations/m5-session-3-building-a-harness.pptx
+++ b/presentations/m5-session-3-building-a-harness.pptx
@@ -943,7 +943,7 @@
           <a:lstStyle/>
           <a:p>
             <a:r>
-              <a:t>Left: the researcher lists the workflows folder, reads notebooks.yml and answers on turn three - Python 3.12, nine notebooks, the file path - so the loop returns done; 3,536 input tokens in all because every turn re-sends the whole conversation. Middle: the same agent with max_turns=2 spends both turns on tools and the harness cuts it with an empty answer; that is the seatbelt working. Right: a 3,000-token budget; after README.md comes back, count_tokens says the next call would carry 7,342 tokens, so the harness stops before sending it and nothing is billed for that call. Class question: which of the two cut runs would you rather explain to the person paying the bill, and why? Figures on this slide are quoted from the recorded run of notebook 03 on 30 Sep 2026 (claude-opus-5 main agents, claude-sonnet-5 workers); live runs vary, so compare shapes and reasons, not digits.</a:t>
+              <a:t>Left: the researcher lists the workflows folder, reads notebooks.yml and answers on turn three - Python 3.12, nine notebooks, the file path - so the loop returns done; 3,536 input tokens in all because every turn re-sends the whole conversation. Middle: the same agent with max_turns=2 spends both turns on tools and the harness cuts it with an empty answer; that is the seatbelt working. Right: a 3,000-token budget; after README.md comes back, count_tokens says the next call would carry 7,341 tokens, so the harness stops before sending it: one model call made, turns=1, nothing billed for the call that was counted. Turns count model calls, not tool calls, so the budget run has one turn. Class question: which of the two cut runs would you rather explain to the person paying the bill, and why? Figures on this slide are quoted from the recorded run of notebook 03 on 30 Sep 2026 (claude-opus-5 main agents, claude-sonnet-5 workers); live runs vary, so compare shapes and reasons, not digits.</a:t>
             </a:r>
           </a:p>
         </p:txBody>
@@ -1363,7 +1363,7 @@
           <a:lstStyle/>
           <a:p>
             <a:r>
-              <a:t>A scoreboard hides the interesting part. The left column is not a hallucination story: A never invented a fact, it said it could not know, eleven times, and the grader rightly failed it because the fact is in the repository. The right column is the surprise: the only failure of the full harness is a trap, and the same trap was the most expensive case for B as well. Eight turns of listing and reading for a grade that does not exist. B happened to answer on its last turn; C was still calling tools when the seatbelt engaged. Class question: how would you change the system prompt so the model stops searching after two empty looks - and how would you test that it worked? Figures on this slide are quoted from the recorded run of notebook 03 on 30 Sep 2026 (claude-opus-5 main agents, claude-sonnet-5 workers); live runs vary, so compare shapes and reasons, not digits.</a:t>
+              <a:t>A scoreboard hides the interesting part. The left column is not a hallucination story: A never invented a fact, it said it could not know, eleven times, and the grader rightly failed it because the fact is in the repository. The right column is the surprise: the only failure of the full harness is a trap, and the same trap was the most expensive case for B as well. The system prompt says never guess, so the model tries to prove that no grade exists by reading file after file; nothing tells it when to stop. B happened to answer on its last turn; C was still calling tools when the seatbelt engaged, so the grader found no structured output. Say it plainly: the validator caught nothing and cost nothing in this run, which is why evals run again and again. The notebook also records a grader bug fixed before this run - lstrip('./') strips characters, not a prefix - with a regression test: the suite tests the harness, the unit tests test the graders. Class question: how would you change the system prompt so the model stops searching after two empty looks - and how would you test that it worked? Figures on this slide are quoted from the recorded run of notebook 03 on 30 Sep 2026 (claude-opus-5 main agents, claude-sonnet-5 workers); live runs vary, so compare shapes and reasons, not digits.</a:t>
             </a:r>
           </a:p>
         </p:txBody>
@@ -12319,7 +12319,7 @@
                 </a:solidFill>
                 <a:latin typeface="Arial"/>
               </a:rPr>
-              <a:t>The grader wanted the fact and the file; the model was honest and still wrong - it has no way to reach the answer</a:t>
+              <a:t>Honest and useless at the same time: the grader asks for the fact and its source, and no fact was invented</a:t>
             </a:r>
           </a:p>
           <a:p>
@@ -12339,7 +12339,7 @@
                 </a:solidFill>
                 <a:latin typeface="Arial"/>
               </a:rPr>
-              <a:t>Its three passes are the traps, where found=False was the right answer</a:t>
+              <a:t>Its three passes are the traps, where 'the repository does not contain it' happens to be right</a:t>
             </a:r>
           </a:p>
           <a:p>
@@ -12359,7 +12359,7 @@
                 </a:solidFill>
                 <a:latin typeface="Arial"/>
               </a:rPr>
-              <a:t>In plain words: without tools, the model can only pass the questions whose answer is 'I do not know'</a:t>
+              <a:t>In plain words: a model without tools cannot do a task that requires reading</a:t>
             </a:r>
           </a:p>
         </p:txBody>
@@ -12506,7 +12506,7 @@
                 </a:solidFill>
                 <a:latin typeface="Arial"/>
               </a:rPr>
-              <a:t>B on the same case: also 8 turns, found=False on the last turn, $0.5341 - the dearest case in both suites</a:t>
+              <a:t>B on the same case: also 8 turns, found=False on the last turn, $0.5341 - 'never guess' makes the model prove a negative, file after file</a:t>
             </a:r>
           </a:p>
           <a:p>
@@ -12526,7 +12526,7 @@
                 </a:solidFill>
                 <a:latin typeface="Arial"/>
               </a:rPr>
-              <a:t>The model kept searching a repository that holds no grade; whether it speaks before turn eight is luck, not design</a:t>
+              <a:t>The validator never fired: require_sources did not fire once in 14 cases, so C's lower score and higher cost are not its doing</a:t>
             </a:r>
           </a:p>
           <a:p>
@@ -12546,7 +12546,7 @@
                 </a:solidFill>
                 <a:latin typeface="Arial"/>
               </a:rPr>
-              <a:t>The failure print shows no trace, so we cannot say whether the validator fired; the seatbelt is what we can see</a:t>
+              <a:t>Same model, same question, two runs: a result from one run is a reading, not a verdict</a:t>
             </a:r>
           </a:p>
           <a:p>
@@ -12566,7 +12566,7 @@
                 </a:solidFill>
                 <a:latin typeface="Arial"/>
               </a:rPr>
-              <a:t>Fix in the harness, not the model: a tighter max_turns or a system prompt that says when to stop looking</a:t>
+              <a:t>Change next, cheapest first: tell the model when to stop searching; count a max_turns stop with no answer as found=False; add a max_input_tokens budget</a:t>
             </a:r>
           </a:p>
         </p:txBody>
@@ -12606,7 +12606,7 @@
                 </a:solidFill>
                 <a:latin typeface="Arial"/>
               </a:rPr>
-              <a:t>Notebook 03 section 4, 'The failures, one by one'. A trap case tests honesty and the seatbelt at once: write it into the suite or you will never see it. Recorded run, 30 Sep 2026; live runs vary.</a:t>
+              <a:t>Notebook 03 section 4, 'Reading the failures honestly'. Proving a negative is the most expensive thing you can ask an agent to do. Recorded run, 30 Sep 2026; live runs vary.</a:t>
             </a:r>
           </a:p>
         </p:txBody>

</xml_diff>